<commit_message>
Add themes to hypernetworks: weight-generation task-adaptation weight-space-learning
Decks (pptx/pdf), spec.json, figures and README for each theme, field.json,
and the generated branch README.

Co-Authored-By: Claude Opus 5.5 <noreply@anthropic.com>
Claude-Session: https://claude.ai/code/session_01XCo1fEaxRp1ZKVxVZ14mEu
</commit_message>
<xml_diff>
--- a/task-adaptation/task-adaptation.pptx
+++ b/task-adaptation/task-adaptation.pptx
@@ -2681,6 +2681,563 @@
 
 <file path=ppt/slideLayouts/slideLayout3.xml><?xml version="1.0" encoding="utf-8"?>
 <p:sldLayout xmlns:a="http://schemas.openxmlformats.org/drawingml/2006/main" xmlns:r="http://schemas.openxmlformats.org/officeDocument/2006/relationships" xmlns:p="http://schemas.openxmlformats.org/presentationml/2006/main" preserve="1">
+  <p:cSld name="OCHIAI_PAPER_DETAIL">
+    <p:bg>
+      <p:bgPr>
+        <a:solidFill>
+          <a:srgbClr val="FFFFFF"/>
+        </a:solidFill>
+      </p:bgPr>
+    </p:bg>
+    <p:spTree>
+      <p:nvGrpSpPr>
+        <p:cNvPr id="1" name=""/>
+        <p:cNvGrpSpPr/>
+        <p:nvPr/>
+      </p:nvGrpSpPr>
+      <p:grpSpPr>
+        <a:xfrm>
+          <a:off x="0" y="0"/>
+          <a:ext cx="0" cy="0"/>
+          <a:chOff x="0" y="0"/>
+          <a:chExt cx="0" cy="0"/>
+        </a:xfrm>
+      </p:grpSpPr>
+      <p:sp>
+        <p:nvSpPr>
+          <p:cNvPr id="2" name="Shape 0"/>
+          <p:cNvSpPr/>
+          <p:nvPr/>
+        </p:nvSpPr>
+        <p:spPr>
+          <a:xfrm>
+            <a:off x="457200" y="1508760"/>
+            <a:ext cx="7772400" cy="4800600"/>
+          </a:xfrm>
+          <a:prstGeom prst="rect">
+            <a:avLst>
+              <a:gd name="adj" fmla="val 1524"/>
+            </a:avLst>
+          </a:prstGeom>
+          <a:solidFill>
+            <a:srgbClr val="F2F4F8"/>
+          </a:solidFill>
+          <a:ln/>
+        </p:spPr>
+      </p:sp>
+      <p:sp>
+        <p:nvSpPr>
+          <p:cNvPr id="3" name="Text 1"/>
+          <p:cNvSpPr/>
+          <p:nvPr/>
+        </p:nvSpPr>
+        <p:spPr>
+          <a:xfrm>
+            <a:off x="621792" y="1600200"/>
+            <a:ext cx="7443216" cy="347472"/>
+          </a:xfrm>
+          <a:prstGeom prst="rect">
+            <a:avLst/>
+          </a:prstGeom>
+          <a:noFill/>
+          <a:ln/>
+        </p:spPr>
+        <p:txBody>
+          <a:bodyPr wrap="square" lIns="0" tIns="0" rIns="0" bIns="0" rtlCol="0" anchor="ctr"/>
+          <a:lstStyle/>
+          <a:p>
+            <a:pPr indent="0" marL="0">
+              <a:buNone/>
+            </a:pPr>
+            <a:r>
+              <a:rPr lang="en-US" sz="1300" b="1" dirty="0">
+                <a:solidFill>
+                  <a:srgbClr val="1F6F78"/>
+                </a:solidFill>
+                <a:latin typeface="Meiryo" pitchFamily="34" charset="0"/>
+                <a:ea typeface="Meiryo" pitchFamily="34" charset="-122"/>
+                <a:cs typeface="Meiryo" pitchFamily="34" charset="-120"/>
+              </a:rPr>
+              <a:t>詳細</a:t>
+            </a:r>
+            <a:endParaRPr lang="en-US" sz="1300" dirty="0"/>
+          </a:p>
+        </p:txBody>
+      </p:sp>
+      <p:sp>
+        <p:nvSpPr>
+          <p:cNvPr id="4" name="Text 2"/>
+          <p:cNvSpPr/>
+          <p:nvPr>
+            <p:ph idx="102" type="body" hasCustomPrompt="1"/>
+          </p:nvPr>
+        </p:nvSpPr>
+        <p:spPr>
+          <a:xfrm>
+            <a:off x="621792" y="1984248"/>
+            <a:ext cx="7443216" cy="4251960"/>
+          </a:xfrm>
+          <a:prstGeom prst="rect">
+            <a:avLst/>
+          </a:prstGeom>
+          <a:noFill/>
+          <a:ln/>
+        </p:spPr>
+        <p:txBody>
+          <a:bodyPr wrap="square" rtlCol="0"/>
+          <a:lstStyle>
+            <a:lvl1pPr indent="0" marL="0">
+              <a:buNone/>
+              <a:defRPr lang="en-US" sz="1200" dirty="0">
+                <a:solidFill>
+                  <a:srgbClr val="1E2433"/>
+                </a:solidFill>
+                <a:latin typeface="Meiryo" pitchFamily="34" charset="0"/>
+                <a:ea typeface="Meiryo" pitchFamily="34" charset="-122"/>
+                <a:cs typeface="Meiryo" pitchFamily="34" charset="-120"/>
+              </a:defRPr>
+            </a:lvl1pPr>
+          </a:lstStyle>
+          <a:p>
+            <a:pPr indent="0" marL="0">
+              <a:buNone/>
+            </a:pPr>
+            <a:endParaRPr lang="en-US" sz="1200" dirty="0"/>
+          </a:p>
+        </p:txBody>
+      </p:sp>
+      <p:sp>
+        <p:nvSpPr>
+          <p:cNvPr id="5" name="Shape 2"/>
+          <p:cNvSpPr/>
+          <p:nvPr/>
+        </p:nvSpPr>
+        <p:spPr>
+          <a:xfrm>
+            <a:off x="8366760" y="1508760"/>
+            <a:ext cx="3367735" cy="1234440"/>
+          </a:xfrm>
+          <a:prstGeom prst="rect">
+            <a:avLst>
+              <a:gd name="adj" fmla="val 5926"/>
+            </a:avLst>
+          </a:prstGeom>
+          <a:solidFill>
+            <a:srgbClr val="F2F4F8"/>
+          </a:solidFill>
+          <a:ln/>
+        </p:spPr>
+      </p:sp>
+      <p:sp>
+        <p:nvSpPr>
+          <p:cNvPr id="6" name="Text 3"/>
+          <p:cNvSpPr/>
+          <p:nvPr/>
+        </p:nvSpPr>
+        <p:spPr>
+          <a:xfrm>
+            <a:off x="8531352" y="1600200"/>
+            <a:ext cx="3038551" cy="347472"/>
+          </a:xfrm>
+          <a:prstGeom prst="rect">
+            <a:avLst/>
+          </a:prstGeom>
+          <a:noFill/>
+          <a:ln/>
+        </p:spPr>
+        <p:txBody>
+          <a:bodyPr wrap="square" lIns="0" tIns="0" rIns="0" bIns="0" rtlCol="0" anchor="ctr"/>
+          <a:lstStyle/>
+          <a:p>
+            <a:pPr indent="0" marL="0">
+              <a:buNone/>
+            </a:pPr>
+            <a:r>
+              <a:rPr lang="en-US" sz="1300" b="1" dirty="0">
+                <a:solidFill>
+                  <a:srgbClr val="1F6F78"/>
+                </a:solidFill>
+                <a:latin typeface="Meiryo" pitchFamily="34" charset="0"/>
+                <a:ea typeface="Meiryo" pitchFamily="34" charset="-122"/>
+                <a:cs typeface="Meiryo" pitchFamily="34" charset="-120"/>
+              </a:rPr>
+              <a:t>受賞・注目</a:t>
+            </a:r>
+            <a:endParaRPr lang="en-US" sz="1300" dirty="0"/>
+          </a:p>
+        </p:txBody>
+      </p:sp>
+      <p:sp>
+        <p:nvSpPr>
+          <p:cNvPr id="7" name="Text 4"/>
+          <p:cNvSpPr/>
+          <p:nvPr>
+            <p:ph idx="105" type="body" hasCustomPrompt="1"/>
+          </p:nvPr>
+        </p:nvSpPr>
+        <p:spPr>
+          <a:xfrm>
+            <a:off x="8531352" y="1984248"/>
+            <a:ext cx="3038551" cy="685800"/>
+          </a:xfrm>
+          <a:prstGeom prst="rect">
+            <a:avLst/>
+          </a:prstGeom>
+          <a:noFill/>
+          <a:ln/>
+        </p:spPr>
+        <p:txBody>
+          <a:bodyPr wrap="square" rtlCol="0"/>
+          <a:lstStyle>
+            <a:lvl1pPr indent="0" marL="0">
+              <a:buNone/>
+              <a:defRPr lang="en-US" sz="1200" dirty="0">
+                <a:solidFill>
+                  <a:srgbClr val="1E2433"/>
+                </a:solidFill>
+                <a:latin typeface="Meiryo" pitchFamily="34" charset="0"/>
+                <a:ea typeface="Meiryo" pitchFamily="34" charset="-122"/>
+                <a:cs typeface="Meiryo" pitchFamily="34" charset="-120"/>
+              </a:defRPr>
+            </a:lvl1pPr>
+          </a:lstStyle>
+          <a:p>
+            <a:pPr indent="0" marL="0">
+              <a:buNone/>
+            </a:pPr>
+            <a:endParaRPr lang="en-US" sz="1200" dirty="0"/>
+          </a:p>
+        </p:txBody>
+      </p:sp>
+      <p:sp>
+        <p:nvSpPr>
+          <p:cNvPr id="8" name="Shape 4"/>
+          <p:cNvSpPr/>
+          <p:nvPr/>
+        </p:nvSpPr>
+        <p:spPr>
+          <a:xfrm>
+            <a:off x="8366760" y="2880360"/>
+            <a:ext cx="3367735" cy="3429000"/>
+          </a:xfrm>
+          <a:prstGeom prst="rect">
+            <a:avLst>
+              <a:gd name="adj" fmla="val 2172"/>
+            </a:avLst>
+          </a:prstGeom>
+          <a:solidFill>
+            <a:srgbClr val="F2F4F8"/>
+          </a:solidFill>
+          <a:ln/>
+        </p:spPr>
+      </p:sp>
+      <p:sp>
+        <p:nvSpPr>
+          <p:cNvPr id="9" name="Text 5"/>
+          <p:cNvSpPr/>
+          <p:nvPr/>
+        </p:nvSpPr>
+        <p:spPr>
+          <a:xfrm>
+            <a:off x="8531352" y="2971800"/>
+            <a:ext cx="3038551" cy="347472"/>
+          </a:xfrm>
+          <a:prstGeom prst="rect">
+            <a:avLst/>
+          </a:prstGeom>
+          <a:noFill/>
+          <a:ln/>
+        </p:spPr>
+        <p:txBody>
+          <a:bodyPr wrap="square" lIns="0" tIns="0" rIns="0" bIns="0" rtlCol="0" anchor="ctr"/>
+          <a:lstStyle/>
+          <a:p>
+            <a:pPr indent="0" marL="0">
+              <a:buNone/>
+            </a:pPr>
+            <a:r>
+              <a:rPr lang="en-US" sz="1300" b="1" dirty="0">
+                <a:solidFill>
+                  <a:srgbClr val="1F6F78"/>
+                </a:solidFill>
+                <a:latin typeface="Meiryo" pitchFamily="34" charset="0"/>
+                <a:ea typeface="Meiryo" pitchFamily="34" charset="-122"/>
+                <a:cs typeface="Meiryo" pitchFamily="34" charset="-120"/>
+              </a:rPr>
+              <a:t>評価ポイント</a:t>
+            </a:r>
+            <a:endParaRPr lang="en-US" sz="1300" dirty="0"/>
+          </a:p>
+        </p:txBody>
+      </p:sp>
+      <p:sp>
+        <p:nvSpPr>
+          <p:cNvPr id="10" name="Text 6"/>
+          <p:cNvSpPr/>
+          <p:nvPr>
+            <p:ph idx="108" type="body" hasCustomPrompt="1"/>
+          </p:nvPr>
+        </p:nvSpPr>
+        <p:spPr>
+          <a:xfrm>
+            <a:off x="8531352" y="3355848"/>
+            <a:ext cx="3038551" cy="2880360"/>
+          </a:xfrm>
+          <a:prstGeom prst="rect">
+            <a:avLst/>
+          </a:prstGeom>
+          <a:noFill/>
+          <a:ln/>
+        </p:spPr>
+        <p:txBody>
+          <a:bodyPr wrap="square" rtlCol="0"/>
+          <a:lstStyle>
+            <a:lvl1pPr indent="0" marL="0">
+              <a:buNone/>
+              <a:defRPr lang="en-US" sz="1200" dirty="0">
+                <a:solidFill>
+                  <a:srgbClr val="1E2433"/>
+                </a:solidFill>
+                <a:latin typeface="Meiryo" pitchFamily="34" charset="0"/>
+                <a:ea typeface="Meiryo" pitchFamily="34" charset="-122"/>
+                <a:cs typeface="Meiryo" pitchFamily="34" charset="-120"/>
+              </a:defRPr>
+            </a:lvl1pPr>
+          </a:lstStyle>
+          <a:p>
+            <a:pPr indent="0" marL="0">
+              <a:buNone/>
+            </a:pPr>
+            <a:endParaRPr lang="en-US" sz="1200" dirty="0"/>
+          </a:p>
+        </p:txBody>
+      </p:sp>
+      <p:sp>
+        <p:nvSpPr>
+          <p:cNvPr id="11" name="Text 6"/>
+          <p:cNvSpPr/>
+          <p:nvPr>
+            <p:ph idx="109" type="body" hasCustomPrompt="1"/>
+          </p:nvPr>
+        </p:nvSpPr>
+        <p:spPr>
+          <a:xfrm>
+            <a:off x="457200" y="274320"/>
+            <a:ext cx="11277295" cy="256032"/>
+          </a:xfrm>
+          <a:prstGeom prst="rect">
+            <a:avLst/>
+          </a:prstGeom>
+          <a:noFill/>
+          <a:ln/>
+        </p:spPr>
+        <p:txBody>
+          <a:bodyPr wrap="square" rtlCol="0"/>
+          <a:lstStyle>
+            <a:lvl1pPr indent="0" marL="0">
+              <a:buNone/>
+              <a:defRPr lang="en-US" sz="1100" b="1" dirty="0">
+                <a:solidFill>
+                  <a:srgbClr val="1F6F78"/>
+                </a:solidFill>
+                <a:latin typeface="Meiryo" pitchFamily="34" charset="0"/>
+                <a:ea typeface="Meiryo" pitchFamily="34" charset="-122"/>
+                <a:cs typeface="Meiryo" pitchFamily="34" charset="-120"/>
+              </a:defRPr>
+            </a:lvl1pPr>
+          </a:lstStyle>
+          <a:p>
+            <a:pPr indent="0" marL="0">
+              <a:buNone/>
+            </a:pPr>
+            <a:endParaRPr lang="en-US" sz="1100" dirty="0"/>
+          </a:p>
+        </p:txBody>
+      </p:sp>
+      <p:sp>
+        <p:nvSpPr>
+          <p:cNvPr id="12" name="Text 6"/>
+          <p:cNvSpPr/>
+          <p:nvPr>
+            <p:ph idx="110" type="body" hasCustomPrompt="1"/>
+          </p:nvPr>
+        </p:nvSpPr>
+        <p:spPr>
+          <a:xfrm>
+            <a:off x="457200" y="530352"/>
+            <a:ext cx="11277295" cy="566928"/>
+          </a:xfrm>
+          <a:prstGeom prst="rect">
+            <a:avLst/>
+          </a:prstGeom>
+          <a:noFill/>
+          <a:ln/>
+        </p:spPr>
+        <p:txBody>
+          <a:bodyPr wrap="square" rtlCol="0"/>
+          <a:lstStyle>
+            <a:lvl1pPr indent="0" marL="0">
+              <a:buNone/>
+              <a:defRPr lang="en-US" sz="2400" b="1" dirty="0">
+                <a:solidFill>
+                  <a:srgbClr val="1E2433"/>
+                </a:solidFill>
+                <a:latin typeface="Meiryo" pitchFamily="34" charset="0"/>
+                <a:ea typeface="Meiryo" pitchFamily="34" charset="-122"/>
+                <a:cs typeface="Meiryo" pitchFamily="34" charset="-120"/>
+              </a:defRPr>
+            </a:lvl1pPr>
+          </a:lstStyle>
+          <a:p>
+            <a:pPr indent="0" marL="0">
+              <a:buNone/>
+            </a:pPr>
+            <a:endParaRPr lang="en-US" sz="2400" dirty="0"/>
+          </a:p>
+        </p:txBody>
+      </p:sp>
+      <p:sp>
+        <p:nvSpPr>
+          <p:cNvPr id="13" name="Text 6"/>
+          <p:cNvSpPr/>
+          <p:nvPr>
+            <p:ph idx="111" type="body" hasCustomPrompt="1"/>
+          </p:nvPr>
+        </p:nvSpPr>
+        <p:spPr>
+          <a:xfrm>
+            <a:off x="457200" y="1115568"/>
+            <a:ext cx="11277295" cy="274320"/>
+          </a:xfrm>
+          <a:prstGeom prst="rect">
+            <a:avLst/>
+          </a:prstGeom>
+          <a:noFill/>
+          <a:ln/>
+        </p:spPr>
+        <p:txBody>
+          <a:bodyPr wrap="square" rtlCol="0"/>
+          <a:lstStyle>
+            <a:lvl1pPr indent="0" marL="0">
+              <a:buNone/>
+              <a:defRPr lang="en-US" sz="1200" dirty="0">
+                <a:solidFill>
+                  <a:srgbClr val="5B6478"/>
+                </a:solidFill>
+                <a:latin typeface="Meiryo" pitchFamily="34" charset="0"/>
+                <a:ea typeface="Meiryo" pitchFamily="34" charset="-122"/>
+                <a:cs typeface="Meiryo" pitchFamily="34" charset="-120"/>
+              </a:defRPr>
+            </a:lvl1pPr>
+          </a:lstStyle>
+          <a:p>
+            <a:pPr indent="0" marL="0">
+              <a:buNone/>
+            </a:pPr>
+            <a:endParaRPr lang="en-US" sz="1200" dirty="0"/>
+          </a:p>
+        </p:txBody>
+      </p:sp>
+      <p:sp>
+        <p:nvSpPr>
+          <p:cNvPr id="14" name="Text 6"/>
+          <p:cNvSpPr/>
+          <p:nvPr>
+            <p:ph idx="112" type="body" hasCustomPrompt="1"/>
+          </p:nvPr>
+        </p:nvSpPr>
+        <p:spPr>
+          <a:xfrm>
+            <a:off x="457200" y="6446520"/>
+            <a:ext cx="9144000" cy="274320"/>
+          </a:xfrm>
+          <a:prstGeom prst="rect">
+            <a:avLst/>
+          </a:prstGeom>
+          <a:noFill/>
+          <a:ln/>
+        </p:spPr>
+        <p:txBody>
+          <a:bodyPr wrap="square" rtlCol="0"/>
+          <a:lstStyle>
+            <a:lvl1pPr indent="0" marL="0">
+              <a:buNone/>
+              <a:defRPr lang="en-US" sz="1000" dirty="0">
+                <a:solidFill>
+                  <a:srgbClr val="5B6478"/>
+                </a:solidFill>
+                <a:latin typeface="Meiryo" pitchFamily="34" charset="0"/>
+                <a:ea typeface="Meiryo" pitchFamily="34" charset="-122"/>
+                <a:cs typeface="Meiryo" pitchFamily="34" charset="-120"/>
+              </a:defRPr>
+            </a:lvl1pPr>
+          </a:lstStyle>
+          <a:p>
+            <a:pPr indent="0" marL="0">
+              <a:buNone/>
+            </a:pPr>
+            <a:endParaRPr lang="en-US" sz="1000" dirty="0"/>
+          </a:p>
+        </p:txBody>
+      </p:sp>
+      <p:sp>
+        <p:nvSpPr>
+          <p:cNvPr id="25" name="Slide Number Placeholder 0"/>
+          <p:cNvSpPr>
+            <a:spLocks noGrp="1"/>
+          </p:cNvSpPr>
+          <p:nvPr>
+            <p:ph type="sldNum" sz="quarter" idx="4294967295"/>
+          </p:nvPr>
+        </p:nvSpPr>
+        <p:spPr>
+          <a:xfrm>
+            <a:off x="11185855" y="6446520"/>
+            <a:ext cx="548640" cy="274320"/>
+          </a:xfrm>
+          <a:prstGeom prst="rect">
+            <a:avLst/>
+          </a:prstGeom>
+          <a:extLst>
+            <a:ext uri="{C572A759-6A51-4108-AA02-DFA0A04FC94B}">
+              <ma14:wrappingTextBoxFlag xmlns:ma14="http://schemas.microsoft.com/office/mac/drawingml/2011/main" val="0"/>
+            </a:ext>
+          </a:extLst>
+        </p:spPr>
+        <p:txBody>
+          <a:bodyPr/>
+          <a:lstStyle>
+            <a:lvl1pPr>
+              <a:defRPr sz="1000">
+                <a:solidFill>
+                  <a:srgbClr val="5B6478"/>
+                </a:solidFill>
+                <a:latin typeface="Meiryo"/>
+                <a:ea typeface="Meiryo"/>
+                <a:cs typeface="Meiryo"/>
+              </a:defRPr>
+            </a:lvl1pPr>
+          </a:lstStyle>
+          <a:p>
+            <a:pPr algn="r"/>
+            <a:fld id="{F7021451-1387-4CA6-816F-3879F97B5CBC}" type="slidenum">
+              <a:rPr b="0" lang="en-US"/>
+              <a:t>1003</a:t>
+            </a:fld>
+            <a:endParaRPr lang="en-US"/>
+          </a:p>
+        </p:txBody>
+      </p:sp>
+    </p:spTree>
+  </p:cSld>
+  <p:clrMapOvr>
+    <a:masterClrMapping/>
+  </p:clrMapOvr>
+</p:sldLayout>
+</file>
+
+<file path=ppt/slideLayouts/slideLayout4.xml><?xml version="1.0" encoding="utf-8"?>
+<p:sldLayout xmlns:a="http://schemas.openxmlformats.org/drawingml/2006/main" xmlns:r="http://schemas.openxmlformats.org/officeDocument/2006/relationships" xmlns:p="http://schemas.openxmlformats.org/presentationml/2006/main" preserve="1">
   <p:cSld name="OCHIAI_COVER">
     <p:bg>
       <p:bgPr>
@@ -2913,7 +3470,7 @@
             <a:pPr algn="r"/>
             <a:fld id="{F7021451-1387-4CA6-816F-3879F97B5CBC}" type="slidenum">
               <a:rPr b="0" lang="en-US"/>
-              <a:t>1003</a:t>
+              <a:t>1004</a:t>
             </a:fld>
             <a:endParaRPr lang="en-US"/>
           </a:p>
@@ -2999,6 +3556,7 @@
     <p:sldLayoutId id="2147483649" r:id="rId1"/>
     <p:sldLayoutId id="2147483650" r:id="rId2"/>
     <p:sldLayoutId id="2147483651" r:id="rId3"/>
+    <p:sldLayoutId id="2147483652" r:id="rId4"/>
   </p:sldLayoutIdLst>
   <p:hf sldNum="0" hdr="0" ftr="0" dt="0"/>
   <p:txStyles>
@@ -10990,7 +11548,7 @@
                 <a:ea typeface="Meiryo" pitchFamily="34" charset="-122"/>
                 <a:cs typeface="Meiryo" pitchFamily="34" charset="-120"/>
               </a:rPr>
-              <a:t>各訓練 MDP で TD3 を 100万ステップ学習して最適軌跡を集め、文脈 (ψ, μ) から方策 π̂ と価値 Q̂ の重みを生成。行動・価値の予測損失に、生成した π̂ と Q̂ がベルマン方程式で整合する TD 正則化を加えた教師あり学習。</a:t>
+              <a:t>各訓練 MDP で TD3 を 100万ステップ学習して最適軌跡を集め、文脈 (ψ, μ) から方策 π と価値 Q の重みを生成。行動・価値の予測損失に、生成した π と Q がベルマン方程式で整合する TD 正則化を加えた教師あり学習。</a:t>
             </a:r>
             <a:endParaRPr lang="en-US" sz="1200" dirty="0"/>
           </a:p>

</xml_diff>